<commit_message>
geneNetworking: add context-dependent TF slide (FOXA1/SPI1 cocktail→target switching) to deck
</commit_message>
<xml_diff>
--- a/geneNetworking/geneNetworking_bulkRNAseq.pptx
+++ b/geneNetworking/geneNetworking_bulkRNAseq.pptx
@@ -13,6 +13,7 @@
     <p:sldId id="261" r:id="rId12"/>
     <p:sldId id="262" r:id="rId13"/>
     <p:sldId id="263" r:id="rId14"/>
+    <p:sldId id="266" r:id="rId17"/>
     <p:sldId id="264" r:id="rId15"/>
     <p:sldId id="265" r:id="rId16"/>
   </p:sldIdLst>
@@ -3411,7 +3412,7 @@
                 </a:solidFill>
                 <a:latin typeface="Calibri"/>
               </a:rPr>
-              <a:t>10 / 10</a:t>
+              <a:t>11 / 11</a:t>
             </a:r>
           </a:p>
         </p:txBody>
@@ -3594,6 +3595,194 @@
                 <a:latin typeface="Calibri"/>
               </a:rPr>
               <a:t>– Next: single-cell confirmation (in progress) + genome-scale orthogroups/motif layer</a:t>
+            </a:r>
+          </a:p>
+        </p:txBody>
+      </p:sp>
+    </p:spTree>
+  </p:cSld>
+  <p:clrMapOvr>
+    <a:masterClrMapping/>
+  </p:clrMapOvr>
+</p:sld>
+</file>
+
+<file path=ppt/slides/slide11.xml><?xml version="1.0" encoding="utf-8"?>
+<p:sld xmlns:a="http://schemas.openxmlformats.org/drawingml/2006/main" xmlns:p="http://schemas.openxmlformats.org/presentationml/2006/main" xmlns:r="http://schemas.openxmlformats.org/officeDocument/2006/relationships">
+  <p:cSld>
+    <p:spTree>
+      <p:nvGrpSpPr>
+        <p:cNvPr id="1" name=""/>
+        <p:cNvGrpSpPr/>
+        <p:nvPr/>
+      </p:nvGrpSpPr>
+      <p:grpSpPr/>
+      <p:sp>
+        <p:nvSpPr>
+          <p:cNvPr id="2" name="Rectangle 1"/>
+          <p:cNvSpPr/>
+          <p:nvPr/>
+        </p:nvSpPr>
+        <p:spPr>
+          <a:xfrm>
+            <a:off x="0" y="0"/>
+            <a:ext cx="12191695" cy="109728"/>
+          </a:xfrm>
+          <a:prstGeom prst="rect">
+            <a:avLst/>
+          </a:prstGeom>
+          <a:solidFill>
+            <a:srgbClr val="2A7D8B"/>
+          </a:solidFill>
+          <a:ln>
+            <a:noFill/>
+          </a:ln>
+        </p:spPr>
+        <p:style>
+          <a:lnRef idx="1">
+            <a:schemeClr val="accent1"/>
+          </a:lnRef>
+          <a:fillRef idx="3">
+            <a:schemeClr val="accent1"/>
+          </a:fillRef>
+          <a:effectRef idx="2">
+            <a:schemeClr val="accent1"/>
+          </a:effectRef>
+          <a:fontRef idx="minor">
+            <a:schemeClr val="lt1"/>
+          </a:fontRef>
+        </p:style>
+        <p:txBody>
+          <a:bodyPr rtlCol="0" anchor="ctr"/>
+          <a:lstStyle/>
+          <a:p>
+            <a:pPr algn="ctr"/>
+          </a:p>
+        </p:txBody>
+      </p:sp>
+      <p:sp>
+        <p:nvSpPr>
+          <p:cNvPr id="3" name="TextBox 2"/>
+          <p:cNvSpPr txBox="1"/>
+          <p:nvPr/>
+        </p:nvSpPr>
+        <p:spPr>
+          <a:xfrm>
+            <a:off x="502920" y="256032"/>
+            <a:ext cx="11155680" cy="822960"/>
+          </a:xfrm>
+          <a:prstGeom prst="rect">
+            <a:avLst/>
+          </a:prstGeom>
+          <a:noFill/>
+        </p:spPr>
+        <p:txBody>
+          <a:bodyPr wrap="square">
+            <a:spAutoFit/>
+          </a:bodyPr>
+          <a:lstStyle/>
+          <a:p>
+            <a:r>
+              <a:rPr sz="2500" b="1">
+                <a:solidFill>
+                  <a:srgbClr val="1F3A5F"/>
+                </a:solidFill>
+                <a:latin typeface="Calibri"/>
+              </a:rPr>
+              <a:t>Context-Dependent Regulation — One TF, Different Cocktails, Different Targets</a:t>
+            </a:r>
+          </a:p>
+        </p:txBody>
+      </p:sp>
+      <p:pic>
+        <p:nvPicPr>
+          <p:cNvPr id="4" name="Picture 3" descr="v9080669a_slide_context_TF.png"/>
+          <p:cNvPicPr>
+            <a:picLocks noChangeAspect="1"/>
+          </p:cNvPicPr>
+          <p:nvPr/>
+        </p:nvPicPr>
+        <p:blipFill>
+          <a:blip r:embed="rId2"/>
+          <a:stretch>
+            <a:fillRect/>
+          </a:stretch>
+        </p:blipFill>
+        <p:spPr>
+          <a:xfrm>
+            <a:off x="1340967" y="1143000"/>
+            <a:ext cx="9509760" cy="4635646"/>
+          </a:xfrm>
+          <a:prstGeom prst="rect">
+            <a:avLst/>
+          </a:prstGeom>
+        </p:spPr>
+      </p:pic>
+      <p:sp>
+        <p:nvSpPr>
+          <p:cNvPr id="5" name="TextBox 4"/>
+          <p:cNvSpPr txBox="1"/>
+          <p:nvPr/>
+        </p:nvSpPr>
+        <p:spPr>
+          <a:xfrm>
+            <a:off x="548640" y="5806440"/>
+            <a:ext cx="11064240" cy="868680"/>
+          </a:xfrm>
+          <a:prstGeom prst="rect">
+            <a:avLst/>
+          </a:prstGeom>
+          <a:noFill/>
+        </p:spPr>
+        <p:txBody>
+          <a:bodyPr wrap="square">
+            <a:spAutoFit/>
+          </a:bodyPr>
+          <a:lstStyle/>
+          <a:p>
+            <a:pPr algn="ctr"/>
+            <a:r>
+              <a:rPr sz="1150" i="1">
+                <a:solidFill>
+                  <a:srgbClr val="444444"/>
+                </a:solidFill>
+                <a:latin typeface="Calibri"/>
+              </a:rPr>
+              <a:t>Directly answers the motivating question. FOXA1 (a pioneer factor) and SPI1/PU.1 (a combinatorial regulator) each control completely non-overlapping gene sets (0% target overlap) in different tissues — and the SHAP-inferred partner cocktail differs with them: FOXA1+GRHL2 drives epithelial genes (SPDEF, TMPRSS2) in salivary gland, FOXA1+NR1I3/CAR drives xenobiotic metabolism (CYP3A5, UGT1A1) in liver.</a:t>
+            </a:r>
+          </a:p>
+        </p:txBody>
+      </p:sp>
+      <p:sp>
+        <p:nvSpPr>
+          <p:cNvPr id="6" name="TextBox 5"/>
+          <p:cNvSpPr txBox="1"/>
+          <p:nvPr/>
+        </p:nvSpPr>
+        <p:spPr>
+          <a:xfrm>
+            <a:off x="11247120" y="6382512"/>
+            <a:ext cx="822960" cy="365760"/>
+          </a:xfrm>
+          <a:prstGeom prst="rect">
+            <a:avLst/>
+          </a:prstGeom>
+          <a:noFill/>
+        </p:spPr>
+        <p:txBody>
+          <a:bodyPr wrap="none">
+            <a:spAutoFit/>
+          </a:bodyPr>
+          <a:lstStyle/>
+          <a:p>
+            <a:pPr algn="r"/>
+            <a:r>
+              <a:rPr sz="1100">
+                <a:solidFill>
+                  <a:srgbClr val="666666"/>
+                </a:solidFill>
+              </a:rPr>
+              <a:t>9 / 11</a:t>
             </a:r>
           </a:p>
         </p:txBody>
@@ -3732,7 +3921,7 @@
                 </a:solidFill>
                 <a:latin typeface="Calibri"/>
               </a:rPr>
-              <a:t>2 / 10</a:t>
+              <a:t>2 / 11</a:t>
             </a:r>
           </a:p>
         </p:txBody>
@@ -4006,7 +4195,7 @@
                 </a:solidFill>
                 <a:latin typeface="Calibri"/>
               </a:rPr>
-              <a:t>3 / 10</a:t>
+              <a:t>3 / 11</a:t>
             </a:r>
           </a:p>
         </p:txBody>
@@ -4697,7 +4886,7 @@
                 </a:solidFill>
                 <a:latin typeface="Calibri"/>
               </a:rPr>
-              <a:t>4 / 10</a:t>
+              <a:t>4 / 11</a:t>
             </a:r>
           </a:p>
         </p:txBody>
@@ -5051,7 +5240,7 @@
                 </a:solidFill>
                 <a:latin typeface="Calibri"/>
               </a:rPr>
-              <a:t>5 / 10</a:t>
+              <a:t>5 / 11</a:t>
             </a:r>
           </a:p>
         </p:txBody>
@@ -5365,7 +5554,7 @@
                 </a:solidFill>
                 <a:latin typeface="Calibri"/>
               </a:rPr>
-              <a:t>6 / 10</a:t>
+              <a:t>6 / 11</a:t>
             </a:r>
           </a:p>
         </p:txBody>
@@ -5695,7 +5884,7 @@
                 </a:solidFill>
                 <a:latin typeface="Calibri"/>
               </a:rPr>
-              <a:t>7 / 10</a:t>
+              <a:t>7 / 11</a:t>
             </a:r>
           </a:p>
         </p:txBody>
@@ -6009,7 +6198,7 @@
                 </a:solidFill>
                 <a:latin typeface="Calibri"/>
               </a:rPr>
-              <a:t>8 / 10</a:t>
+              <a:t>8 / 11</a:t>
             </a:r>
           </a:p>
         </p:txBody>
@@ -6235,7 +6424,7 @@
                 </a:solidFill>
                 <a:latin typeface="Calibri"/>
               </a:rPr>
-              <a:t>9 / 10</a:t>
+              <a:t>10 / 11</a:t>
             </a:r>
           </a:p>
         </p:txBody>

</xml_diff>